<commit_message>
Pre-compute expanded-predictor variant (panel+run in progress), subperiod figure on deck slide 8, script arg extensions
</commit_message>
<xml_diff>
--- a/deck/EC4308_Presentation.pptx
+++ b/deck/EC4308_Presentation.pptx
@@ -5015,16 +5015,40 @@
           </a:p>
         </p:txBody>
       </p:sp>
-      <p:sp>
-        <p:nvSpPr>
-          <p:cNvPr id="3" name="TextBox 2"/>
+      <p:pic>
+        <p:nvPicPr>
+          <p:cNvPr id="3" name="Picture 2" descr="figure4_subperiods.png"/>
+          <p:cNvPicPr>
+            <a:picLocks noChangeAspect="1"/>
+          </p:cNvPicPr>
+          <p:nvPr/>
+        </p:nvPicPr>
+        <p:blipFill>
+          <a:blip r:embed="rId2"/>
+          <a:stretch>
+            <a:fillRect/>
+          </a:stretch>
+        </p:blipFill>
+        <p:spPr>
+          <a:xfrm>
+            <a:off x="548640" y="1371600"/>
+            <a:ext cx="5669280" cy="3401568"/>
+          </a:xfrm>
+          <a:prstGeom prst="rect">
+            <a:avLst/>
+          </a:prstGeom>
+        </p:spPr>
+      </p:pic>
+      <p:sp>
+        <p:nvSpPr>
+          <p:cNvPr id="4" name="TextBox 3"/>
           <p:cNvSpPr txBox="1"/>
           <p:nvPr/>
         </p:nvSpPr>
         <p:spPr>
           <a:xfrm>
-            <a:off x="640080" y="1280160"/>
-            <a:ext cx="10881360" cy="4937760"/>
+            <a:off x="6400800" y="1371600"/>
+            <a:ext cx="5394960" cy="4572000"/>
           </a:xfrm>
           <a:prstGeom prst="rect">
             <a:avLst/>

</xml_diff>